<commit_message>
Update the 3 step-question slides with user's edited wording
Apply the edits made directly on the exported slides: refined investment-horizon and capital questions on step 1, dropped "change of designation" from step 2's value-add options, and expanded step 3's execution question to cover the financial profiling stage.

Co-Authored-By: Claude Sonnet 5 <noreply@anthropic.com>
Claude-Session: https://claude.ai/code/session_01EjvgZ41mYnmscy7ggfbTfs
</commit_message>
<xml_diff>
--- a/downloads/tlv-webinar-deck.pptx
+++ b/downloads/tlv-webinar-deck.pptx
@@ -3569,7 +3569,7 @@
                 <a:ea typeface="Calibri" pitchFamily="34" charset="-122"/>
                 <a:cs typeface="Calibri" pitchFamily="34" charset="-120"/>
               </a:rPr>
-              <a:t>מה ההון הפנוי האמיתי שלי להשקעה, אחרי עלויות נלוות (מס רכישה, שכר טרחה, שיפוץ)?</a:t>
+              <a:t>מה ההון הפנוי להשקעה בתל אביב?</a:t>
             </a:r>
             <a:endParaRPr lang="en-US" sz="1350" dirty="0"/>
           </a:p>
@@ -3636,7 +3636,7 @@
                 <a:ea typeface="Calibri" pitchFamily="34" charset="-122"/>
                 <a:cs typeface="Calibri" pitchFamily="34" charset="-120"/>
               </a:rPr>
-              <a:t>האם אני מחפש הכנסה שוטפת משכירות, או עליית ערך לטווח בינוני-ארוך?</a:t>
+              <a:t>האם אני מחפש הכנסה שוטפת משכירות, או עליית ערך משמעותית לטווח קצר או בינוני-ארוך? (תלוי סטטוס דירה יחידה או דירה להשקעה)</a:t>
             </a:r>
             <a:endParaRPr lang="en-US" sz="1350" dirty="0"/>
           </a:p>
@@ -3703,7 +3703,7 @@
                 <a:ea typeface="Calibri" pitchFamily="34" charset="-122"/>
                 <a:cs typeface="Calibri" pitchFamily="34" charset="-120"/>
               </a:rPr>
-              <a:t>מה טווח הזמן הריאלי שלי: 12 חודשים, 3 שנים, או אופק ארוך יותר?</a:t>
+              <a:t>מה טווח הזמן הריאלי שלי: 18 חודשים, 3 שנים, או אופק ארוך יותר?</a:t>
             </a:r>
             <a:endParaRPr lang="en-US" sz="1350" dirty="0"/>
           </a:p>
@@ -4124,7 +4124,7 @@
                 <a:ea typeface="Calibri" pitchFamily="34" charset="-122"/>
                 <a:cs typeface="Calibri" pitchFamily="34" charset="-120"/>
               </a:rPr>
-              <a:t>האם יש אפשרות ממשית להשבחה: שיפוץ, פיצול, שינוי ייעוד, או התחדשות עירונית?</a:t>
+              <a:t>האם יש אפשרות ממשית להשבחה: שיפוץ, פיצול, או התחדשות עירונית?</a:t>
             </a:r>
             <a:endParaRPr lang="en-US" sz="1350" dirty="0"/>
           </a:p>
@@ -6514,7 +6514,7 @@
                 <a:ea typeface="Calibri" pitchFamily="34" charset="-122"/>
                 <a:cs typeface="Calibri" pitchFamily="34" charset="-120"/>
               </a:rPr>
-              <a:t>מי מלווה את הביצוע בפועל: קבלן, מתכנן, עורך דין, יועץ מיסוי?</a:t>
+              <a:t>מי מלווה את התהליך משלב האפיון הפיננסי ועד היעד, מי מלווה את הביצוע בפועל: קבלן, מתכנן, עורך דין, יועץ מיסוי?</a:t>
             </a:r>
             <a:endParaRPr lang="en-US" sz="1350" dirty="0"/>
           </a:p>

</xml_diff>